<commit_message>
Tighten the template deck to a full academic register
Rewrites every slide in third person with the hedging and precision the
register asks for, and drops the conversational turns the earlier draft
carried over from the standalone deck.

Adds the scholarly apparatus the deck was missing. The background slide
now sources its two headline figures rather than asserting them; a
seventeenth slide carries the reference list, Hebrew entries before
English ones with hanging indents; and every slide is numbered. The
eleven in-text citations and the eleven reference entries cross-check in
both directions.

Speaker notes were rewritten in the same register. The layout checker
and schema validation both pass on the seventeen slide deck, and the six
participant quotes remain verbatim.

Co-Authored-By: Claude Fable 5 <noreply@anthropic.com>
Claude-Session: https://claude.ai/code/session_01Aebwgiv2BDsZYZ7oiMCAJ9
</commit_message>
<xml_diff>
--- a/seminar-interviews/מצגת-פרויקט-גמר-תבנית-המכללה.pptx
+++ b/seminar-interviews/מצגת-פרויקט-גמר-תבנית-המכללה.pptx
@@ -21,6 +21,7 @@
     <p:sldId id="271" r:id="rId15"/>
     <p:sldId id="267" r:id="rId16"/>
     <p:sldId id="266" r:id="rId17"/>
+    <p:sldId id="272" r:id="rId22"/>
   </p:sldIdLst>
   <p:sldSz cx="12192000" cy="6858000"/>
   <p:notesSz cx="6858000" cy="9144000"/>
@@ -170,7 +171,7 @@
             <a:pPr algn="r" rtl="1"/>
             <a:r>
               <a:rPr lang="he-IL" sz="1200" dirty="0"/>
-              <a:t>פתיחה קצרה: נושא הפרויקט, שמות המגישות והמנחה. כחצי דקה.</a:t>
+              <a:t>הצגת נושא הפרויקט, שמות המגישות והמנחה. כחצי דקה.</a:t>
             </a:r>
           </a:p>
         </p:txBody>
@@ -226,7 +227,7 @@
             <a:pPr algn="r" rtl="1"/>
             <a:r>
               <a:rPr lang="he-IL" sz="1200" dirty="0"/>
-              <a:t>מפת הדרכים לשני השקפים הבאים. לומר את השורה התחתונה: ההיענות היא מאזן כוחות ולא רמת ידע.</a:t>
+              <a:t>מפת התמות משמשת מסגרת לשני השקפים הבאים. לנסח את המסקנה המרכזית העולה ממנה.</a:t>
             </a:r>
           </a:p>
         </p:txBody>
@@ -282,7 +283,7 @@
             <a:pPr algn="r" rtl="1"/>
             <a:r>
               <a:rPr lang="he-IL" sz="1200" dirty="0"/>
-              <a:t>להקריא את הציטוטים במלואם. הם הראיה, לא הקישוט.</a:t>
+              <a:t>להקריא את הציטוטים במלואם, בהיותם הראיה האמפירית לתמות.</a:t>
             </a:r>
           </a:p>
         </p:txBody>
@@ -338,7 +339,7 @@
             <a:pPr algn="r" rtl="1"/>
             <a:r>
               <a:rPr lang="he-IL" sz="1200" dirty="0"/>
-              <a:t>זו התמה שהפתיעה אותנו. להסביר למה חסם כזה לא נראה בשאלונים.</a:t>
+              <a:t>להדגיש כי מדובר בחסם שאינו מתועד די הצורך בספרות, ולהסביר מדוע אינו נלכד בשאלונים.</a:t>
             </a:r>
           </a:p>
         </p:txBody>
@@ -394,7 +395,7 @@
             <a:pPr algn="r" rtl="1"/>
             <a:r>
               <a:rPr lang="he-IL" sz="1200" dirty="0"/>
-              <a:t>שלוש השאלות באמצע הפסקה הן הלב של הסיכום.</a:t>
+              <a:t>שלושת התנאים המפורטים באמצע הפסקה הם ליבת הסיכום.</a:t>
             </a:r>
           </a:p>
         </p:txBody>
@@ -450,7 +451,7 @@
             <a:pPr algn="r" rtl="1"/>
             <a:r>
               <a:rPr lang="he-IL" sz="1200" dirty="0"/>
-              <a:t>להציג את הממצא הדתי כהפתעה ולא כמסקנה חותכת, עם הסתייגות על גודל המדגם.</a:t>
+              <a:t>להציג את הממצא בדבר הממד הדתי כממצא החורג מן הצפוי, בליווי הסתייגות בדבר גודל המדגם.</a:t>
             </a:r>
           </a:p>
         </p:txBody>
@@ -506,7 +507,7 @@
             <a:pPr algn="r" rtl="1"/>
             <a:r>
               <a:rPr lang="he-IL" sz="1200" dirty="0"/>
-              <a:t>השקף החשוב ביותר להערכה, כי החוברת מבקשת יישומיות. לחבר כל המלצה לתמה שממנה נולדה.</a:t>
+              <a:t>לקשור כל המלצה לתמה שממנה נגזרה, ולהבחין בין רמת המרפאה לרמת המדיניות.</a:t>
             </a:r>
           </a:p>
         </p:txBody>
@@ -562,7 +563,63 @@
             <a:pPr algn="r" rtl="1"/>
             <a:r>
               <a:rPr lang="he-IL" sz="1200" dirty="0"/>
-              <a:t>לא להתנצל. להציג את המגבלות כמודעות מתודולוגית ולעבור לכיווני ההמשך.</a:t>
+              <a:t>להציג את המגבלות כמודעות מתודולוגית, ולעבור לכיווני מחקר ההמשך.</a:t>
+            </a:r>
+          </a:p>
+        </p:txBody>
+      </p:sp>
+    </p:spTree>
+  </p:cSld>
+  <p:clrMapOvr>
+    <a:masterClrMapping/>
+  </p:clrMapOvr>
+</p:notes>
+</file>
+
+<file path=ppt/notesSlides/notesSlide17.xml><?xml version="1.0" encoding="utf-8"?>
+<p:notes xmlns:a="http://schemas.openxmlformats.org/drawingml/2006/main" xmlns:r="http://schemas.openxmlformats.org/officeDocument/2006/relationships" xmlns:p="http://schemas.openxmlformats.org/presentationml/2006/main">
+  <p:cSld>
+    <p:spTree>
+      <p:nvGrpSpPr>
+        <p:cNvPr id="1" name=""/>
+        <p:cNvGrpSpPr/>
+        <p:nvPr/>
+      </p:nvGrpSpPr>
+      <p:grpSpPr>
+        <a:xfrm>
+          <a:off x="0" y="0"/>
+          <a:ext cx="0" cy="0"/>
+          <a:chOff x="0" y="0"/>
+          <a:chExt cx="0" cy="0"/>
+        </a:xfrm>
+      </p:grpSpPr>
+      <p:sp>
+        <p:nvSpPr>
+          <p:cNvPr id="2" name="מציין מיקום טקסט של הערות"/>
+          <p:cNvSpPr>
+            <a:spLocks noGrp="1"/>
+          </p:cNvSpPr>
+          <p:nvPr>
+            <p:ph type="body" idx="1"/>
+          </p:nvPr>
+        </p:nvSpPr>
+        <p:spPr>
+          <a:xfrm>
+            <a:off x="685800" y="685800"/>
+            <a:ext cx="5486400" cy="4114800"/>
+          </a:xfrm>
+          <a:prstGeom prst="rect">
+            <a:avLst/>
+          </a:prstGeom>
+        </p:spPr>
+        <p:txBody>
+          <a:bodyPr/>
+          <a:lstStyle/>
+          <a:p>
+            <a:pPr algn="r" rtl="1"/>
+            <a:r>
+              <a:rPr lang="he-IL" sz="1200" dirty="0"/>
+              <a:t>שקף המקורות מוצג בקצרה; רשימת המקורות המלאה מופיעה בגוף העבודה.</a:t>
             </a:r>
           </a:p>
         </p:txBody>
@@ -618,7 +675,7 @@
             <a:pPr algn="r" rtl="1"/>
             <a:r>
               <a:rPr lang="he-IL" sz="1200" dirty="0"/>
-              <a:t>להדגיש שהבדיקה חינמית לשתי הקבוצות, ולכן הפער אינו כלכלי. המספרים הם הבסיס לכל העבודה.</a:t>
+              <a:t>להדגיש כי הבדיקה נגישה וחינמית לשתי הקבוצות, ומכאן שהפער אינו מוסבר בחסם כלכלי.</a:t>
             </a:r>
           </a:p>
         </p:txBody>
@@ -674,7 +731,7 @@
             <a:pPr algn="r" rtl="1"/>
             <a:r>
               <a:rPr lang="he-IL" sz="1200" dirty="0"/>
-              <a:t>לקרוא את שאלת המחקר בקול. להסביר שבמחקר איכותני אין השערות.</a:t>
+              <a:t>להקריא את שאלת המחקר. לציין כי במחקר איכותני לא מוצבות השערות.</a:t>
             </a:r>
           </a:p>
         </p:txBody>
@@ -730,7 +787,7 @@
             <a:pPr algn="r" rtl="1"/>
             <a:r>
               <a:rPr lang="he-IL" sz="1200" dirty="0"/>
-              <a:t>לא למנות את כל החסמים. להתעכב על המשפט המודגש בסוף, שהפערים מצטמצמים אחרי תקנון.</a:t>
+              <a:t>להציג את שלוש משפחות החסמים בקצרה, ולהתעכב על ממצא התקנון הסוציו-דמוגרפי.</a:t>
             </a:r>
           </a:p>
         </p:txBody>
@@ -786,7 +843,7 @@
             <a:pPr algn="r" rtl="1"/>
             <a:r>
               <a:rPr lang="he-IL" sz="1200" dirty="0"/>
-              <a:t>המשפט החשוב הוא הפער בין ידע להתנהגות. הוא מוביל ישירות לשאלת המחקר שלנו.</a:t>
+              <a:t>הנקודה המרכזית היא הפער בין ידע להתנהגות, המוביל אל שאלת המחקר.</a:t>
             </a:r>
           </a:p>
         </p:txBody>
@@ -842,7 +899,7 @@
             <a:pPr algn="r" rtl="1"/>
             <a:r>
               <a:rPr lang="he-IL" sz="1200" dirty="0"/>
-              <a:t>להסביר במשפט אחד למה המודלים הקלאסיים אינם מספיקים כאן ולמה בחרנו בגישה הסוציו-אקולוגית.</a:t>
+              <a:t>להסביר מדוע המודלים הקלאסיים אינם מספקים בהקשר קולקטיביסטי, ומהי תרומת הגישה הסוציו-אקולוגית.</a:t>
             </a:r>
           </a:p>
         </p:txBody>
@@ -898,7 +955,7 @@
             <a:pPr algn="r" rtl="1"/>
             <a:r>
               <a:rPr lang="he-IL" sz="1200" dirty="0"/>
-              <a:t>להסביר למה איכותני ולא שאלון. להדגיש את השונוּת המכוונת במדגם.</a:t>
+              <a:t>לנמק את בחירת השיטה האיכותנית ולהדגיש את השונוּת המכוונת שנבנתה במדגם.</a:t>
             </a:r>
           </a:p>
         </p:txBody>
@@ -954,7 +1011,7 @@
             <a:pPr algn="r" rtl="1"/>
             <a:r>
               <a:rPr lang="he-IL" sz="1200" dirty="0"/>
-              <a:t>לא להקריא את הטבלה. להצביע על שלוש שורות: מי שנבדקת בקביעות, מי שמעולם לא נבדקה, ומי שחלתה.</a:t>
+              <a:t>אין להקריא את הטבלה. להצביע על שלוש שורות המייצגות את קצות הטווח ואת המקרה של האישה שחלתה.</a:t>
             </a:r>
           </a:p>
         </p:txBody>
@@ -1010,7 +1067,7 @@
             <a:pPr algn="r" rtl="1"/>
             <a:r>
               <a:rPr lang="he-IL" sz="1200" dirty="0"/>
-              <a:t>להזכיר את הפיילוט ואת הסוגיה האתית. זה מראה התמודדות עם דילמה אמיתית ולא מילוי טופס.</a:t>
+              <a:t>לציין את ראיון הפיילוט ואת אופן הטיפול בסוגיות האתיות.</a:t>
             </a:r>
           </a:p>
         </p:txBody>
@@ -4629,6 +4686,29 @@
           </a:prstGeom>
         </p:spPr>
       </p:pic>
+      <p:sp>
+        <p:nvSpPr>
+          <p:cNvPr id="31" name="מציין מיקום של מספר שקופית"/>
+          <p:cNvSpPr>
+            <a:spLocks noGrp="1"/>
+          </p:cNvSpPr>
+          <p:nvPr>
+            <p:ph type="sldNum" sz="quarter" idx="12"/>
+          </p:nvPr>
+        </p:nvSpPr>
+        <p:spPr/>
+        <p:txBody>
+          <a:bodyPr/>
+          <a:lstStyle/>
+          <a:p>
+            <a:pPr algn="l" rtl="0"/>
+            <a:fld id="{2D6E5B1F-8A4C-4B71-9E3A-000000000010}" type="slidenum">
+              <a:rPr lang="he-IL" sz="1200"/>
+              <a:t>10</a:t>
+            </a:fld>
+          </a:p>
+        </p:txBody>
+      </p:sp>
     </p:spTree>
     <p:extLst>
       <p:ext uri="{BB962C8B-B14F-4D97-AF65-F5344CB8AC3E}">
@@ -4740,7 +4820,7 @@
               <a:rPr lang="he-IL" sz="2200" dirty="0">
                 <a:cs typeface="+mn-cs"/>
               </a:rPr>
-              <a:t>התמה הראשונה מלמדת כי </a:t>
+              <a:t>מן התמה הראשונה עולה כי </a:t>
             </a:r>
             <a:r>
               <a:rPr lang="he-IL" sz="2200" b="1" dirty="0">
@@ -4749,13 +4829,13 @@
                 </a:solidFill>
                 <a:cs typeface="+mn-cs"/>
               </a:rPr>
-              <a:t>הידע כמעט אינו מבחין בין נשים שנבדקות לבין נשים שאינן נבדקות</a:t>
+              <a:t>הידע אינו מבחין בין נשים הנבדקות לבין נשים שאינן נבדקות</a:t>
             </a:r>
             <a:r>
               <a:rPr lang="he-IL" sz="2200" dirty="0">
                 <a:cs typeface="+mn-cs"/>
               </a:rPr>
-              <a:t>. אחת עשרה מתוך שתים עשרה המשתתפות, ובהן גם אלו שמעולם לא נבדקו, ידעו מהי הבדיקה ולשם מה היא נועדה, ולילה בת ה-54 ניסחה זאת בעצמה: </a:t>
+              <a:t>. אחת עשרה מתוך שתים עשרה המשתתפות, ובהן אלה שמעולם לא נבדקו, ידעו מהי הבדיקה ולשם מה היא נועדה. לילה, בת 54, ניסחה זאת במפורש: </a:t>
             </a:r>
             <a:r>
               <a:rPr lang="he-IL" sz="2200" i="1" dirty="0">
@@ -4770,7 +4850,7 @@
               <a:rPr lang="he-IL" sz="2200" dirty="0">
                 <a:cs typeface="+mn-cs"/>
               </a:rPr>
-              <a:t>. מה שעמד בין הידע לפעולה היה הפחד מן התוצאה ולא מן הבדיקה, ומראם בת ה-52 הבחינה ביניהם במפורש: </a:t>
+              <a:t>. הגורם המעכב שזוהה הוא החשש מפני האבחנה ולא מפני הבדיקה עצמה, כפי שהבחינה מראם, בת 52: </a:t>
             </a:r>
             <a:r>
               <a:rPr lang="he-IL" sz="2200" i="1" dirty="0">
@@ -4785,7 +4865,7 @@
               <a:rPr lang="he-IL" sz="2200" dirty="0">
                 <a:cs typeface="+mn-cs"/>
               </a:rPr>
-              <a:t>. לצידם פעלו האמונה שגוף שאינו כואב אינו זקוק לבדיקה, ומנגנון של דחייה מוצדקת שאינו מגיע לעולם לנקודת הכרעה. התמה השנייה מראה כי חסם הבושה קיים אך ממוקם אחרת מכפי שמניחה הספרות. החשיפה בחדר הבדיקה מול בודקת אישה תוארה כרגע קצר, ואילו מה שהרתיע היה החשיפה החברתית בדרך אל הבדיקה, כפי שתיארה עאליה בת ה-47: </a:t>
+              <a:t>. לצידו פעלו התפיסה כי בהיעדר תסמין אין הצדקה לבדיקה, ודפוס של דחייה מוצדקת שאינו מגיע לכלל הכרעה. התמה השנייה מלמדת כי חסם הבושה קיים אך ממוקם אחרת מכפי שמניחה הספרות: החשיפה בחדר הבדיקה בפני בודקת אישה תוארה כאירוע קצר, ואילו הגורם המרתיע היה החשיפה החברתית בדרך אל הבדיקה, כפי שתיארה עאליה, בת 47: </a:t>
             </a:r>
             <a:r>
               <a:rPr lang="he-IL" sz="2200" i="1" dirty="0">
@@ -4841,6 +4921,29 @@
           </a:prstGeom>
         </p:spPr>
       </p:pic>
+      <p:sp>
+        <p:nvSpPr>
+          <p:cNvPr id="31" name="מציין מיקום של מספר שקופית"/>
+          <p:cNvSpPr>
+            <a:spLocks noGrp="1"/>
+          </p:cNvSpPr>
+          <p:nvPr>
+            <p:ph type="sldNum" sz="quarter" idx="12"/>
+          </p:nvPr>
+        </p:nvSpPr>
+        <p:spPr/>
+        <p:txBody>
+          <a:bodyPr/>
+          <a:lstStyle/>
+          <a:p>
+            <a:pPr algn="l" rtl="0"/>
+            <a:fld id="{2D6E5B1F-8A4C-4B71-9E3A-000000000011}" type="slidenum">
+              <a:rPr lang="he-IL" sz="1200"/>
+              <a:t>11</a:t>
+            </a:fld>
+          </a:p>
+        </p:txBody>
+      </p:sp>
     </p:spTree>
     <p:extLst>
       <p:ext uri="{BB962C8B-B14F-4D97-AF65-F5344CB8AC3E}">
@@ -4952,7 +5055,7 @@
               <a:rPr lang="he-IL" sz="2200" dirty="0">
                 <a:cs typeface="+mn-cs"/>
               </a:rPr>
-              <a:t>התמה השלישית היא הממצא שהפתיע ביותר, משום שהוא כמעט אינו מקבל מקום בספרות התרבותית. המשתתפות תיארו את היציאה לבדיקה כחשבון יומיומי מדויק של שעות עבודה שאבדו, של הסעה ושל נטל טיפולי בבית, וטגאיה בת ה-58 העמידה את שני הצדדים זה מול זה: </a:t>
+              <a:t>התמה השלישית חורגת מן המתועד בספרות התרבותית ומצביעה על חסם מעשי שאינו זוכה להתייחסות מספקת. המשתתפות תיארו את היציאה לבדיקה כחשבון כלכלי ומשפחתי מפורש של שעות עבודה שאבדו, של הסעה ושל נטל טיפולי בבית. טגאיה, בת 58, העמידה את שני הצדדים זה מול זה: </a:t>
             </a:r>
             <a:r>
               <a:rPr lang="he-IL" sz="2200" i="1" dirty="0">
@@ -4967,7 +5070,7 @@
               <a:rPr lang="he-IL" sz="2200" dirty="0">
                 <a:cs typeface="+mn-cs"/>
               </a:rPr>
-              <a:t>. מאפיין מרכזי של החסם הזה הוא ש</a:t>
+              <a:t>. מאפיינו המרכזי של חסם זה הוא ש</a:t>
             </a:r>
             <a:r>
               <a:rPr lang="he-IL" sz="2200" b="1" dirty="0">
@@ -4976,13 +5079,13 @@
                 </a:solidFill>
                 <a:cs typeface="+mn-cs"/>
               </a:rPr>
-              <a:t>הנשים אינן מציגות אותו כחסם אלא כעובדת חיים</a:t>
+              <a:t>הוא אינו נתפס אצל האישה כחסם אלא כסדר עדיפויות סביר</a:t>
             </a:r>
             <a:r>
               <a:rPr lang="he-IL" sz="2200" dirty="0">
                 <a:cs typeface="+mn-cs"/>
               </a:rPr>
-              <a:t>, ולכן הוא אינו נראה במדדים המבוססים על דיווח עצמי. התמה הרביעית עוסקת כולה במאיצים ומצביעה על פנייה אישית כגורם החזק ביותר. אותה המלצה עצמה הניבה שתי תוצאות הפוכות בהתאם לאופן מסירתה, ולילה תיארה את הגרסה שלא פעלה: </a:t>
+              <a:t>, ולפיכך אינו נלכד במדדים המבוססים על דיווח עצמי. התמה הרביעית עוסקת במאיצים ומצביעה על הפנייה האישית כגורם המקדם החזק ביותר. אותה המלצה עצמה הניבה תוצאות מנוגדות בהתאם לאופן מסירתה, ולילה תיארה את הגרסה שלא הובילה לפעולה: </a:t>
             </a:r>
             <a:r>
               <a:rPr lang="he-IL" sz="2200" i="1" dirty="0">
@@ -4997,7 +5100,7 @@
               <a:rPr lang="he-IL" sz="2200" dirty="0">
                 <a:cs typeface="+mn-cs"/>
               </a:rPr>
-              <a:t>. לצידה נמצא כי כל המשתתפות הנבדקות בקביעות תיארו דמות מלווה, ואף אחת מן הנשים שלא נבדקו לא תיארה דמות כזאת.</a:t>
+              <a:t>. בנוסף נמצא כי כל המשתתפות הנבדקות בקביעות תיארו דמות מלווה, ואילו אף אחת מן הנשים שלא נבדקו לא תיארה דמות כזאת.</a:t>
             </a:r>
           </a:p>
         </p:txBody>
@@ -5038,6 +5141,29 @@
           </a:prstGeom>
         </p:spPr>
       </p:pic>
+      <p:sp>
+        <p:nvSpPr>
+          <p:cNvPr id="31" name="מציין מיקום של מספר שקופית"/>
+          <p:cNvSpPr>
+            <a:spLocks noGrp="1"/>
+          </p:cNvSpPr>
+          <p:nvPr>
+            <p:ph type="sldNum" sz="quarter" idx="12"/>
+          </p:nvPr>
+        </p:nvSpPr>
+        <p:spPr/>
+        <p:txBody>
+          <a:bodyPr/>
+          <a:lstStyle/>
+          <a:p>
+            <a:pPr algn="l" rtl="0"/>
+            <a:fld id="{2D6E5B1F-8A4C-4B71-9E3A-000000000012}" type="slidenum">
+              <a:rPr lang="he-IL" sz="1200"/>
+              <a:t>12</a:t>
+            </a:fld>
+          </a:p>
+        </p:txBody>
+      </p:sp>
     </p:spTree>
     <p:extLst>
       <p:ext uri="{BB962C8B-B14F-4D97-AF65-F5344CB8AC3E}">
@@ -5146,6 +5272,12 @@
               <a:buNone/>
             </a:pPr>
             <a:r>
+              <a:rPr lang="he-IL" sz="2200" dirty="0">
+                <a:cs typeface="+mn-cs"/>
+              </a:rPr>
+              <a:t>ממצאי המחקר מלמדים כי </a:t>
+            </a:r>
+            <a:r>
               <a:rPr lang="he-IL" sz="2200" b="1" dirty="0">
                 <a:solidFill>
                   <a:srgbClr val="1F3864"/>
@@ -5158,7 +5290,7 @@
               <a:rPr lang="he-IL" sz="2200" dirty="0">
                 <a:cs typeface="+mn-cs"/>
               </a:rPr>
-              <a:t>. ההבדל בין אישה הנבדקת בקביעות לבין אישה שמעולם לא נבדקה לא עבר בשאלה מה היא יודעת, אלא בשלוש שאלות אחרות: אם מישהו פנה אליה אישית, אם היה מי שליווה אותה, ואם היציאה לבדיקה עלתה לה במחיר שהיא יכולה לשלם. מכאן שתי מסקנות בעלות משמעות ניהולית. הראשונה היא שהחסם התרבותי אמיתי אך ממוקם בדרך אל הבדיקה ולא בחדר הבדיקה, כלומר בחשיפה החברתית ולא בחשיפה הגופנית, ולכן התאמה מגדרית של השירות הכרחית אך אינה מספיקה בלי מענה לצורך בדיסקרטיות. השנייה היא שקיים חסם מעשי שאינו מדובר, המחיר של יום עבודה ושל היעדרות מן הבית, והוא אינו מופיע בשאלונים מפני שאינו נחווה כחסם אלא כסדר עדיפויות סביר.</a:t>
+              <a:t>. ההבחנה בין אישה הנבדקת בקביעות לבין אישה שאינה נבדקת אינה עוברת בשאלת הידע, אלא בשלושה תנאים: קיומה של פנייה אישית, קיומה של דמות מלווה, ועלות ההיעדרות הכרוכה ביציאה לבדיקה. מכאן שתי מסקנות בעלות משמעות ניהולית. הראשונה היא כי החסם התרבותי אמיתי אך ממוקם בדרך אל הבדיקה ולא בחדר הבדיקה, כלומר בחשיפה החברתית ולא בחשיפה הגופנית, ולפיכך התאמה מגדרית של השירות היא תנאי הכרחי שאינו מספיק בהיעדר מענה לצורך בדיסקרטיות. השנייה היא כי קיים חסם מעשי שאינו מתועד די הצורך, הכרוך במחיר של יום עבודה ושל היעדרות מן הבית, ואשר אינו עולה בשאלונים משום שאינו נחווה כחסם.</a:t>
             </a:r>
           </a:p>
         </p:txBody>
@@ -5199,6 +5331,29 @@
           </a:prstGeom>
         </p:spPr>
       </p:pic>
+      <p:sp>
+        <p:nvSpPr>
+          <p:cNvPr id="31" name="מציין מיקום של מספר שקופית"/>
+          <p:cNvSpPr>
+            <a:spLocks noGrp="1"/>
+          </p:cNvSpPr>
+          <p:nvPr>
+            <p:ph type="sldNum" sz="quarter" idx="12"/>
+          </p:nvPr>
+        </p:nvSpPr>
+        <p:spPr/>
+        <p:txBody>
+          <a:bodyPr/>
+          <a:lstStyle/>
+          <a:p>
+            <a:pPr algn="l" rtl="0"/>
+            <a:fld id="{2D6E5B1F-8A4C-4B71-9E3A-000000000013}" type="slidenum">
+              <a:rPr lang="he-IL" sz="1200"/>
+              <a:t>13</a:t>
+            </a:fld>
+          </a:p>
+        </p:txBody>
+      </p:sp>
     </p:spTree>
     <p:extLst>
       <p:ext uri="{BB962C8B-B14F-4D97-AF65-F5344CB8AC3E}">
@@ -5310,7 +5465,7 @@
               <a:rPr lang="he-IL" sz="2200" dirty="0">
                 <a:cs typeface="+mn-cs"/>
               </a:rPr>
-              <a:t>מול הספרות, הממצאים מאשרים את קיומם של החסמים המוכרים אך משנים את מיקומם ואת משקלם. הטענה שהידע הוא תנאי הכרחי שאינו מספיק (Alatawneh et al., 2024) מקבלת כאן חיזוק ואף מוקצנת, שכן אצל חלק מן המשתתפות הידע פעל לטובת ההימנעות ולא נגדה. הממצא בדבר מרכזיות המלצת איש המקצוע (Freund et al., 2019) אושר במלואו, אך הראיונות מחדדים שלא תוכן ההמלצה הוא המכריע אלא צורתה. הממצא המפתיע ביותר נוגע לממד הדתי: הספרות מייחסת לפטליזם משקל ניכר (Azaiza et al., 2010), ואילו כאן </a:t>
+              <a:t>בהשוואה לספרות, הממצאים מאששים את קיומם של החסמים המוכרים אך משנים את מיקומם ואת משקלם היחסי. הטענה כי הידע הוא תנאי הכרחי שאינו מספיק (Alatawneh et al., 2024) מקבלת חיזוק, ואף מורחבת, שכן אצל חלק מן המשתתפות תפקד הידע כגורם המסייע להימנעות. הממצא בדבר מרכזיות המלצת ספק השירות (Freund et al., 2019) אושש במלואו, אולם הראיונות מלמדים כי הגורם המכריע אינו תוכן ההמלצה אלא אופן מסירתה. ממצא החורג מן הצפוי נוגע לממד הדתי: בעוד שהספרות מייחסת לפטליזם משקל ניכר (Azaiza et al., 2010), </a:t>
             </a:r>
             <a:r>
               <a:rPr lang="he-IL" sz="2200" b="1" dirty="0">
@@ -5319,13 +5474,13 @@
                 </a:solidFill>
                 <a:cs typeface="+mn-cs"/>
               </a:rPr>
-              <a:t>אף מרואיינת לא נימקה את הימנעותה בטעם דתי</a:t>
+              <a:t>אף אחת מן המשתתפות לא נימקה את הימנעותה בטעם דתי</a:t>
             </a:r>
             <a:r>
               <a:rPr lang="he-IL" sz="2200" dirty="0">
                 <a:cs typeface="+mn-cs"/>
               </a:rPr>
-              <a:t>, ונשים אמרו שהכול בידי שמיים וגם נבדקו בקביעות בלי לראות בכך סתירה. סועאד בת ה-61 ניסחה זאת כך: </a:t>
+              <a:t>, ומשתתפות שהחזיקו באמונה כי הכול בידי שמיים נבדקו בקביעות בלא שראו בכך סתירה. סועאד, בת 61, ניסחה זאת כך: </a:t>
             </a:r>
             <a:r>
               <a:rPr lang="he-IL" sz="2200" i="1" dirty="0">
@@ -5340,7 +5495,7 @@
               <a:rPr lang="he-IL" sz="2200" dirty="0">
                 <a:cs typeface="+mn-cs"/>
               </a:rPr>
-              <a:t>. אם הניסוח הדתי משמש לעיתים כהסבר שנוח למסור לחוקר, הרי שהשקעה בשינוי תפיסות פטליסטיות עשויה להיות פחות יעילה מהסרת חסמים מעשיים.</a:t>
+              <a:t>.</a:t>
             </a:r>
           </a:p>
         </p:txBody>
@@ -5381,6 +5536,29 @@
           </a:prstGeom>
         </p:spPr>
       </p:pic>
+      <p:sp>
+        <p:nvSpPr>
+          <p:cNvPr id="31" name="מציין מיקום של מספר שקופית"/>
+          <p:cNvSpPr>
+            <a:spLocks noGrp="1"/>
+          </p:cNvSpPr>
+          <p:nvPr>
+            <p:ph type="sldNum" sz="quarter" idx="12"/>
+          </p:nvPr>
+        </p:nvSpPr>
+        <p:spPr/>
+        <p:txBody>
+          <a:bodyPr/>
+          <a:lstStyle/>
+          <a:p>
+            <a:pPr algn="l" rtl="0"/>
+            <a:fld id="{2D6E5B1F-8A4C-4B71-9E3A-000000000014}" type="slidenum">
+              <a:rPr lang="he-IL" sz="1200"/>
+              <a:t>14</a:t>
+            </a:fld>
+          </a:p>
+        </p:txBody>
+      </p:sp>
     </p:spTree>
     <p:extLst>
       <p:ext uri="{BB962C8B-B14F-4D97-AF65-F5344CB8AC3E}">
@@ -5492,7 +5670,7 @@
               <a:rPr lang="he-IL" sz="2200" dirty="0">
                 <a:cs typeface="+mn-cs"/>
               </a:rPr>
-              <a:t>ההמלצות נגזרות ישירות מדברי המשתתפות, ומשותף לכולן שהן אינן מנסות לשנות את אמונותיהן של הנשים אלא </a:t>
+              <a:t>ההמלצות נגזרות מן הממצאים, ומשותף לכולן שאין הן מכוונות לשינוי אמונותיהן של הנשים אלא </a:t>
             </a:r>
             <a:r>
               <a:rPr lang="he-IL" sz="2200" b="1" dirty="0">
@@ -5501,13 +5679,13 @@
                 </a:solidFill>
                 <a:cs typeface="+mn-cs"/>
               </a:rPr>
-              <a:t>להסיר את מה שעומד בין האמונה למעשה</a:t>
+              <a:t>להסרת הגורמים החוצצים בין הכוונה לבין הפעולה</a:t>
             </a:r>
             <a:r>
               <a:rPr lang="he-IL" sz="2200" dirty="0">
                 <a:cs typeface="+mn-cs"/>
               </a:rPr>
-              <a:t>. ברמת המרפאה, ובעלות נמוכה יחסית, מומלץ להעמיד רכזת זימונים דוברת ערבית שתפקידה לטלפן ולא לשלוח מכתבים, ולמדוד את שיעור ההמרה משיחה לתור בפועל; להוסיף למערכת הממוחשבת התראה לרופא המשפחה בפתיחת כל ביקור של אישה בגיל הזכאות שאיחרה בבדיקה, כך שההמלצה תינתן במפגש הקליני ולא תישאר תלויה ביוזמת האישה; ולפרוס תורים בשעות אחר הצהריים ובימי שישי לצד אישור היעדרות מעבודה. ברמת הקופה ומשרד הבריאות מומלץ להפעיל את ניידת הממוגרפיה בלוח שנתי קבוע ובמיקום דיסקרטי ולא בחזית המרפאה, להכשיר נשים מקומיות שנבדקו להנחיית מפגשים ביתיים קטנים במקום הרצאות פומביות, ולבחון הרחבה של הזימון היזום לנשים בנות 45 עד 49 בקהילות שבהן חציון גיל האבחון צעיר.</a:t>
+              <a:t>. ברמת המרפאה, ובעלות נמוכה יחסית, מוצע להעמיד רכזת זימונים דוברת ערבית שתפעל בפנייה טלפונית יזומה ולא במשלוח מכתבים, ולמדוד את שיעור ההמרה משיחה לתור שנקבע בפועל; לשלב במערכת הממוחשבת התראה לרופא המשפחה בפתיחת ביקור של אישה בגיל הזכאות שאיחרה בבדיקה, כך שההמלצה תינתן במפגש הקליני; ולהרחיב את פריסת התורים לשעות אחר הצהריים ולימי שישי לצד אישור היעדרות מעבודה. ברמת הקופה ומשרד הבריאות מוצע להפעיל את ניידת הממוגרפיה על פי לוח שנתי קבוע ובמיקום דיסקרטי, להכשיר נשים מקומיות שנבדקו להנחיית מפגשים בהיקף מצומצם, ולבחון הרחבת הזימון היזום לגילאי 45 עד 49 בקהילות שבהן חציון גיל האבחון צעיר.</a:t>
             </a:r>
           </a:p>
         </p:txBody>
@@ -5548,6 +5726,29 @@
           </a:prstGeom>
         </p:spPr>
       </p:pic>
+      <p:sp>
+        <p:nvSpPr>
+          <p:cNvPr id="31" name="מציין מיקום של מספר שקופית"/>
+          <p:cNvSpPr>
+            <a:spLocks noGrp="1"/>
+          </p:cNvSpPr>
+          <p:nvPr>
+            <p:ph type="sldNum" sz="quarter" idx="12"/>
+          </p:nvPr>
+        </p:nvSpPr>
+        <p:spPr/>
+        <p:txBody>
+          <a:bodyPr/>
+          <a:lstStyle/>
+          <a:p>
+            <a:pPr algn="l" rtl="0"/>
+            <a:fld id="{2D6E5B1F-8A4C-4B71-9E3A-000000000015}" type="slidenum">
+              <a:rPr lang="he-IL" sz="1200"/>
+              <a:t>15</a:t>
+            </a:fld>
+          </a:p>
+        </p:txBody>
+      </p:sp>
     </p:spTree>
     <p:extLst>
       <p:ext uri="{BB962C8B-B14F-4D97-AF65-F5344CB8AC3E}">
@@ -5659,7 +5860,7 @@
               <a:rPr lang="he-IL" sz="2200" dirty="0">
                 <a:cs typeface="+mn-cs"/>
               </a:rPr>
-              <a:t>למחקר ארבע מגבלות עיקריות. ראשית, המדגם קטן ומכוון, ולכן אין להסיק ממנו על שכיחותם של החסמים באוכלוסייה אלא רק על הצורות שהם לובשים. שנית, הדגימה בשיטת כדור השלג יצרה הטיה אפשרית לטובת נשים המוכנות לדבר על הנושא, וייתכן שנשים שהימנעותן עמוקה יותר כלל לא הסכימו להתראיין. שלישית, שישה ראיונות נערכו בערבית ובאמהרית ותורגמו לעברית, וכל תרגום כרוך באובדן של גוון. רביעית, שלוש המראיינות הן סטודנטיות למנהל מערכות בריאות, וייתכן שעצם הזיהוי הזה עודד את המרואיינות להציג עמדה חיובית יותר כלפי הבדיקה מזו שהן מחזיקות. מכאן שלושה כיווני המשך: בחינה כמותית של משקל החסם היומיומי לצד החסמים התרבותיים, מחקר השוואתי בין יישובים שבהם פעלה ניידת ממוגרפיה לבין יישובים דומים שבהם לא פעלה, ובחינת ההיענות בקרב נשים מתחת לגיל חמישים בקהילות שבהן חציון גיל האבחון צעיר.</a:t>
+              <a:t>למחקר ארבע מגבלות עיקריות. ראשית, המדגם קטן ומכוון, ולפיכך אין להסיק ממנו על שכיחות החסמים באוכלוסייה אלא על הצורות שהם לובשים בלבד. שנית, הדגימה בשיטת כדור השלג עלולה להטות את המדגם לטובת נשים המוכנות לשוחח על הנושא, וייתכן שנשים שהימנעותן עמוקה יותר לא נכללו בו. שלישית, שישה ראיונות נערכו בערבית ובאמהרית ותורגמו לעברית, ובכל תרגום כרוך אובדן מסוים של ניואנס. רביעית, זהותן של המראיינות כסטודנטיות למנהל מערכות בריאות עשויה הייתה לעודד הצגת עמדה חיובית יותר כלפי הבדיקה. מכאן שלושה כיווני מחקר המשך: בחינה כמותית של משקלו של החסם היומיומי לצד החסמים התרבותיים, מחקר השוואתי בין יישובים שבהם פעלה ניידת ממוגרפיה לבין יישובים דומים שבהם לא פעלה, ובחינת ההיענות בקרב נשים מתחת לגיל חמישים בקהילות שבהן חציון גיל האבחון צעיר.</a:t>
             </a:r>
           </a:p>
         </p:txBody>
@@ -5700,6 +5901,358 @@
           </a:prstGeom>
         </p:spPr>
       </p:pic>
+      <p:sp>
+        <p:nvSpPr>
+          <p:cNvPr id="31" name="מציין מיקום של מספר שקופית"/>
+          <p:cNvSpPr>
+            <a:spLocks noGrp="1"/>
+          </p:cNvSpPr>
+          <p:nvPr>
+            <p:ph type="sldNum" sz="quarter" idx="12"/>
+          </p:nvPr>
+        </p:nvSpPr>
+        <p:spPr/>
+        <p:txBody>
+          <a:bodyPr/>
+          <a:lstStyle/>
+          <a:p>
+            <a:pPr algn="l" rtl="0"/>
+            <a:fld id="{2D6E5B1F-8A4C-4B71-9E3A-000000000016}" type="slidenum">
+              <a:rPr lang="he-IL" sz="1200"/>
+              <a:t>16</a:t>
+            </a:fld>
+          </a:p>
+        </p:txBody>
+      </p:sp>
+    </p:spTree>
+    <p:extLst>
+      <p:ext uri="{BB962C8B-B14F-4D97-AF65-F5344CB8AC3E}">
+        <p14:creationId xmlns:p14="http://schemas.microsoft.com/office/powerpoint/2010/main" val="1136172145"/>
+      </p:ext>
+    </p:extLst>
+  </p:cSld>
+  <p:clrMapOvr>
+    <a:masterClrMapping/>
+  </p:clrMapOvr>
+</p:sld>
+</file>
+
+<file path=ppt/slides/slide17.xml><?xml version="1.0" encoding="utf-8"?>
+<p:sld xmlns:a="http://schemas.openxmlformats.org/drawingml/2006/main" xmlns:r="http://schemas.openxmlformats.org/officeDocument/2006/relationships" xmlns:p="http://schemas.openxmlformats.org/presentationml/2006/main">
+  <p:cSld>
+    <p:spTree>
+      <p:nvGrpSpPr>
+        <p:cNvPr id="1" name="">
+          <a:extLst>
+            <a:ext uri="{FF2B5EF4-FFF2-40B4-BE49-F238E27FC236}">
+              <a16:creationId xmlns:a16="http://schemas.microsoft.com/office/drawing/2014/main" id="{D1D6D8CF-55B1-6D51-F073-64CC9C903369}"/>
+            </a:ext>
+          </a:extLst>
+        </p:cNvPr>
+        <p:cNvGrpSpPr/>
+        <p:nvPr/>
+      </p:nvGrpSpPr>
+      <p:grpSpPr>
+        <a:xfrm>
+          <a:off x="0" y="0"/>
+          <a:ext cx="0" cy="0"/>
+          <a:chOff x="0" y="0"/>
+          <a:chExt cx="0" cy="0"/>
+        </a:xfrm>
+      </p:grpSpPr>
+      <p:sp>
+        <p:nvSpPr>
+          <p:cNvPr id="2" name="כותרת 1">
+            <a:extLst>
+              <a:ext uri="{FF2B5EF4-FFF2-40B4-BE49-F238E27FC236}">
+                <a16:creationId xmlns:a16="http://schemas.microsoft.com/office/drawing/2014/main" id="{48168BB3-4993-2FE3-E6DB-1543F270AB53}"/>
+              </a:ext>
+            </a:extLst>
+          </p:cNvPr>
+          <p:cNvSpPr>
+            <a:spLocks noGrp="1"/>
+          </p:cNvSpPr>
+          <p:nvPr>
+            <p:ph type="title"/>
+          </p:nvPr>
+        </p:nvSpPr>
+        <p:spPr/>
+        <p:txBody>
+          <a:bodyPr/>
+          <a:lstStyle/>
+          <a:p>
+            <a:pPr marL="0" indent="0" algn="r" rtl="1">
+              <a:lnSpc>
+                <a:spcPct val="100000"/>
+              </a:lnSpc>
+              <a:spcBef>
+                <a:spcPts val="0"/>
+              </a:spcBef>
+              <a:buNone/>
+            </a:pPr>
+            <a:r>
+              <a:rPr lang="he-IL" sz="4000" b="1" dirty="0">
+                <a:cs typeface="+mn-cs"/>
+              </a:rPr>
+              <a:t>רשימת מקורות</a:t>
+            </a:r>
+          </a:p>
+        </p:txBody>
+      </p:sp>
+      <p:sp>
+        <p:nvSpPr>
+          <p:cNvPr id="3" name="מציין מיקום תוכן 2">
+            <a:extLst>
+              <a:ext uri="{FF2B5EF4-FFF2-40B4-BE49-F238E27FC236}">
+                <a16:creationId xmlns:a16="http://schemas.microsoft.com/office/drawing/2014/main" id="{E5C98DAF-99C3-F92C-B128-B3554D2ECF23}"/>
+              </a:ext>
+            </a:extLst>
+          </p:cNvPr>
+          <p:cNvSpPr>
+            <a:spLocks noGrp="1"/>
+          </p:cNvSpPr>
+          <p:nvPr>
+            <p:ph idx="1"/>
+          </p:nvPr>
+        </p:nvSpPr>
+        <p:spPr/>
+        <p:txBody>
+          <a:bodyPr>
+            <a:normAutofit/>
+          </a:bodyPr>
+          <a:lstStyle/>
+          <a:p>
+            <a:pPr marL="342900" indent="-342900" algn="r" rtl="1">
+              <a:lnSpc>
+                <a:spcPct val="95000"/>
+              </a:lnSpc>
+              <a:spcBef>
+                <a:spcPts val="300"/>
+              </a:spcBef>
+              <a:buNone/>
+            </a:pPr>
+            <a:r>
+              <a:rPr lang="he-IL" sz="1200" dirty="0">
+                <a:cs typeface="+mn-cs"/>
+              </a:rPr>
+              <a:t>הלשכה המרכזית לסטטיסטיקה (2019). נתוני בריאות האישה בישראל: בדיקות סקר לגילוי מוקדם.</a:t>
+            </a:r>
+          </a:p>
+          <a:p>
+            <a:pPr marL="342900" indent="-342900" algn="r" rtl="1">
+              <a:lnSpc>
+                <a:spcPct val="95000"/>
+              </a:lnSpc>
+              <a:spcBef>
+                <a:spcPts val="300"/>
+              </a:spcBef>
+              <a:buNone/>
+            </a:pPr>
+            <a:r>
+              <a:rPr lang="he-IL" sz="1200" dirty="0">
+                <a:cs typeface="+mn-cs"/>
+              </a:rPr>
+              <a:t>מורן, ד' ס', ואבו עבייד, ס' (2018). היענות נשים ערביות לבדיקות לאבחון מוקדם של סרטן השד במדינות ערב ובישראל: מאמר דעה. כתב עת לפיזיותרפיה, 20(2), 25-32.</a:t>
+            </a:r>
+          </a:p>
+          <a:p>
+            <a:pPr marL="342900" indent="-342900" algn="r" rtl="1">
+              <a:lnSpc>
+                <a:spcPct val="95000"/>
+              </a:lnSpc>
+              <a:spcBef>
+                <a:spcPts val="300"/>
+              </a:spcBef>
+              <a:buNone/>
+            </a:pPr>
+            <a:r>
+              <a:rPr lang="he-IL" sz="1200" dirty="0">
+                <a:cs typeface="+mn-cs"/>
+              </a:rPr>
+              <a:t>סטרן, כ' (2007). היענות לביצוע ממוגרפיה לאור מודלים בקידום בריאות. קידום בריאות בישראל, 1, 34-45.</a:t>
+            </a:r>
+          </a:p>
+          <a:p>
+            <a:pPr marL="342900" indent="-342900" algn="l" rtl="0">
+              <a:lnSpc>
+                <a:spcPct val="95000"/>
+              </a:lnSpc>
+              <a:spcBef>
+                <a:spcPts val="300"/>
+              </a:spcBef>
+              <a:buNone/>
+            </a:pPr>
+            <a:r>
+              <a:rPr lang="en-US" sz="1200" dirty="0"/>
+              <a:t>Alatawneh, D., et al. (2024). Knowledge, age, and perceived social barriers regarding mammography screening among immigrant Arab women in the United States. Journal of Women's Health, 33(10), 1385-1392.</a:t>
+            </a:r>
+          </a:p>
+          <a:p>
+            <a:pPr marL="342900" indent="-342900" algn="l" rtl="0">
+              <a:lnSpc>
+                <a:spcPct val="95000"/>
+              </a:lnSpc>
+              <a:spcBef>
+                <a:spcPts val="300"/>
+              </a:spcBef>
+              <a:buNone/>
+            </a:pPr>
+            <a:r>
+              <a:rPr lang="en-US" sz="1200" dirty="0"/>
+              <a:t>Azaiza, F., Cohen, M., Awad, M., &amp; Daoud, F. (2010). Factors associated with low screening for breast cancer in the Palestinian authority. Cancer, 116(19), 4646-4655.</a:t>
+            </a:r>
+          </a:p>
+          <a:p>
+            <a:pPr marL="342900" indent="-342900" algn="l" rtl="0">
+              <a:lnSpc>
+                <a:spcPct val="95000"/>
+              </a:lnSpc>
+              <a:spcBef>
+                <a:spcPts val="300"/>
+              </a:spcBef>
+              <a:buNone/>
+            </a:pPr>
+            <a:r>
+              <a:rPr lang="en-US" sz="1200" dirty="0"/>
+              <a:t>Ben Shitrit, I., Wang, A., Ilan, K., Agassi, R., Abu Freih, S., &amp; Vaynshtein, J. (2024). Epidemiological, clinical, and pathological characteristics of invasive breast cancer in Bedouin and Jewish women in southern Israel. BMC Cancer, 24, 310.</a:t>
+            </a:r>
+          </a:p>
+          <a:p>
+            <a:pPr marL="342900" indent="-342900" algn="l" rtl="0">
+              <a:lnSpc>
+                <a:spcPct val="95000"/>
+              </a:lnSpc>
+              <a:spcBef>
+                <a:spcPts val="300"/>
+              </a:spcBef>
+              <a:buNone/>
+            </a:pPr>
+            <a:r>
+              <a:rPr lang="en-US" sz="1200" dirty="0"/>
+              <a:t>Cohen, M., &amp; Azaiza, F. (2006). Health beliefs and rates of breast cancer screening among Arab women. Journal of Women's Health, 15(5), 520-530.</a:t>
+            </a:r>
+          </a:p>
+          <a:p>
+            <a:pPr marL="342900" indent="-342900" algn="l" rtl="0">
+              <a:lnSpc>
+                <a:spcPct val="95000"/>
+              </a:lnSpc>
+              <a:spcBef>
+                <a:spcPts val="300"/>
+              </a:spcBef>
+              <a:buNone/>
+            </a:pPr>
+            <a:r>
+              <a:rPr lang="en-US" sz="1200" dirty="0"/>
+              <a:t>Cohen, M., &amp; Azaiza, F. (2008). Increasing breast examinations among Arab women using a tailored culture-based intervention. Behavioral Medicine, 36(3), 92-99.</a:t>
+            </a:r>
+          </a:p>
+          <a:p>
+            <a:pPr marL="342900" indent="-342900" algn="l" rtl="0">
+              <a:lnSpc>
+                <a:spcPct val="95000"/>
+              </a:lnSpc>
+              <a:spcBef>
+                <a:spcPts val="300"/>
+              </a:spcBef>
+              <a:buNone/>
+            </a:pPr>
+            <a:r>
+              <a:rPr lang="en-US" sz="1200" dirty="0"/>
+              <a:t>Freund, A., Cohen, M., &amp; Azaiza, F. (2019). Factors associated with routine screening for the early detection of breast cancer in cultural-ethnic and faith-based communities. Ethnicity &amp; Health, 24(5), 527-543.</a:t>
+            </a:r>
+          </a:p>
+          <a:p>
+            <a:pPr marL="342900" indent="-342900" algn="l" rtl="0">
+              <a:lnSpc>
+                <a:spcPct val="95000"/>
+              </a:lnSpc>
+              <a:spcBef>
+                <a:spcPts val="300"/>
+              </a:spcBef>
+              <a:buNone/>
+            </a:pPr>
+            <a:r>
+              <a:rPr lang="en-US" sz="1200" dirty="0"/>
+              <a:t>Pinchas-Mizrachi, R., &amp; Bouhnik, D. (2024). A retrospective analysis of breast cancer mortality among Jewish and Muslim Arab women in Israel. Cancers, 16(15), 2763.</a:t>
+            </a:r>
+          </a:p>
+          <a:p>
+            <a:pPr marL="342900" indent="-342900" algn="l" rtl="0">
+              <a:lnSpc>
+                <a:spcPct val="95000"/>
+              </a:lnSpc>
+              <a:spcBef>
+                <a:spcPts val="300"/>
+              </a:spcBef>
+              <a:buNone/>
+            </a:pPr>
+            <a:r>
+              <a:rPr lang="en-US" sz="1200" dirty="0"/>
+              <a:t>Soskolne, V., Marie, S., &amp; Manor, O. (2007). Beliefs, recommendations and intentions are important explanatory factors of mammography screening behavior among Muslim Arab women in Israel. Health Education Research, 22(5), 665-676.</a:t>
+            </a:r>
+          </a:p>
+        </p:txBody>
+      </p:sp>
+      <p:pic>
+        <p:nvPicPr>
+          <p:cNvPr id="4" name="Picture 5" descr="תמונה שמכילה טקסט&#10;&#10;התיאור נוצר באופן אוטומטי">
+            <a:extLst>
+              <a:ext uri="{FF2B5EF4-FFF2-40B4-BE49-F238E27FC236}">
+                <a16:creationId xmlns:a16="http://schemas.microsoft.com/office/drawing/2014/main" id="{7D34DE6F-6E8B-E5C0-94B0-7184507AD3FD}"/>
+              </a:ext>
+            </a:extLst>
+          </p:cNvPr>
+          <p:cNvPicPr>
+            <a:picLocks noChangeAspect="1"/>
+          </p:cNvPicPr>
+          <p:nvPr/>
+        </p:nvPicPr>
+        <p:blipFill>
+          <a:blip r:embed="rId2" cstate="print">
+            <a:extLst>
+              <a:ext uri="{28A0092B-C50C-407E-A947-70E740481C1C}">
+                <a14:useLocalDpi xmlns:a14="http://schemas.microsoft.com/office/drawing/2010/main" val="0"/>
+              </a:ext>
+            </a:extLst>
+          </a:blip>
+          <a:stretch>
+            <a:fillRect/>
+          </a:stretch>
+        </p:blipFill>
+        <p:spPr>
+          <a:xfrm>
+            <a:off x="0" y="173817"/>
+            <a:ext cx="2118360" cy="1272540"/>
+          </a:xfrm>
+          <a:prstGeom prst="rect">
+            <a:avLst/>
+          </a:prstGeom>
+        </p:spPr>
+      </p:pic>
+      <p:sp>
+        <p:nvSpPr>
+          <p:cNvPr id="31" name="מציין מיקום של מספר שקופית"/>
+          <p:cNvSpPr>
+            <a:spLocks noGrp="1"/>
+          </p:cNvSpPr>
+          <p:nvPr>
+            <p:ph type="sldNum" sz="quarter" idx="12"/>
+          </p:nvPr>
+        </p:nvSpPr>
+        <p:spPr/>
+        <p:txBody>
+          <a:bodyPr/>
+          <a:lstStyle/>
+          <a:p>
+            <a:pPr algn="l" rtl="0"/>
+            <a:fld id="{2D6E5B1F-8A4C-4B71-9E3A-000000000017}" type="slidenum">
+              <a:rPr lang="he-IL" sz="1200"/>
+              <a:t>17</a:t>
+            </a:fld>
+          </a:p>
+        </p:txBody>
+      </p:sp>
     </p:spTree>
     <p:extLst>
       <p:ext uri="{BB962C8B-B14F-4D97-AF65-F5344CB8AC3E}">
@@ -5805,7 +6358,7 @@
               <a:rPr lang="he-IL" sz="2200" dirty="0">
                 <a:cs typeface="+mn-cs"/>
               </a:rPr>
-              <a:t>סרטן השד הוא הגידול הממאיר השכיח ביותר בקרב נשים בישראל, ובהיעדר אמצעי ודאי למניעה ראשונית נשען המאבק בו על גילוי מוקדם. בדיקת הממוגרפיה ניתנת בישראל ללא תשלום במסגרת סל הבריאות לנשים בגילאי 50 עד 74 אחת לשנתיים, כלומר החסם הכלכלי הוסר זה מכבר. ואף על פי כן, נתוני הסקר החברתי משנת 2017 מלמדים כי בגילאים אלה ביצעו ממוגרפיה </a:t>
+              <a:t>סרטן השד הוא הגידול הממאיר השכיח ביותר בקרב נשים בישראל, ובהיעדר אמצעי ודאי למניעה ראשונית מתמקד המאמץ הרפואי בגילוי מוקדם. בדיקת הממוגרפיה נכללת בסל הבריאות וניתנת ללא תשלום לנשים בגילאי 50 עד 74 אחת לשנתיים, ומכאן שחסם העלות אינו רלוונטי בהקשר הישראלי. חרף זאת מתועד פער מתמשך בשיעורי הביצוע: על פי נתוני הסקר החברתי לשנת 2017 ביצעו ממוגרפיה </a:t>
             </a:r>
             <a:r>
               <a:rPr lang="he-IL" sz="2200" b="1" dirty="0">
@@ -5814,13 +6367,13 @@
                 </a:solidFill>
                 <a:cs typeface="+mn-cs"/>
               </a:rPr>
-              <a:t>78.2 אחוזים מן הנשים היהודיות לעומת 64.8 אחוזים מן הנשים הערביות</a:t>
+              <a:t>78.2% מן הנשים היהודיות לעומת 64.8% מן הנשים הערביות</a:t>
             </a:r>
             <a:r>
               <a:rPr lang="he-IL" sz="2200" dirty="0">
                 <a:cs typeface="+mn-cs"/>
               </a:rPr>
-              <a:t>, ובקרב האחרונות המחלה מאובחנת לעיתים קרובות יותר בשלב מתקדם. הפער חריף במיוחד בנגב, שבו חציון גיל האבחון בקרב נשים בדואיות עומד על כ-48 שנים לעומת כ-62 בקרב נשים יהודיות, כך שחלק ניכר מן התחלואה מתרחש מתחת לגיל שבו תוכנית הסקר מזמנת נשים כלל. </a:t>
+              <a:t> (הלשכה המרכזית לסטטיסטיקה, 2019). לפער זה נלווה הבדל בשלב האבחון ובגיל שבו הוא מתרחש, ובקרב נשים בדואיות בנגב עומד חציון גיל האבחון על כ-48 שנים לעומת כ-62 שנים בקרב נשים יהודיות (Ben Shitrit et al., 2024), כך שחלק ניכר מן התחלואה מתרחש מתחת לגיל הסף של תוכנית הסקר. </a:t>
             </a:r>
             <a:r>
               <a:rPr lang="he-IL" sz="2200" b="1" dirty="0">
@@ -5829,13 +6382,13 @@
                 </a:solidFill>
                 <a:cs typeface="+mn-cs"/>
               </a:rPr>
-              <a:t>הבעיה הניהולית הנגזרת מכאן אינה בעיה של זמינות השירות אלא של ההגעה אליו</a:t>
+              <a:t>הבעיה הניהולית הנגזרת מכך אינה בעיה של זמינות השירות אלא של מימושו בפועל</a:t>
             </a:r>
             <a:r>
               <a:rPr lang="he-IL" sz="2200" dirty="0">
                 <a:cs typeface="+mn-cs"/>
               </a:rPr>
-              <a:t>, ולכן אי אפשר לפתור אותה בהרחבת סל השירותים בלבד.</a:t>
+              <a:t>.</a:t>
             </a:r>
           </a:p>
         </p:txBody>
@@ -5876,6 +6429,29 @@
           </a:prstGeom>
         </p:spPr>
       </p:pic>
+      <p:sp>
+        <p:nvSpPr>
+          <p:cNvPr id="31" name="מציין מיקום של מספר שקופית"/>
+          <p:cNvSpPr>
+            <a:spLocks noGrp="1"/>
+          </p:cNvSpPr>
+          <p:nvPr>
+            <p:ph type="sldNum" sz="quarter" idx="12"/>
+          </p:nvPr>
+        </p:nvSpPr>
+        <p:spPr/>
+        <p:txBody>
+          <a:bodyPr/>
+          <a:lstStyle/>
+          <a:p>
+            <a:pPr algn="l" rtl="0"/>
+            <a:fld id="{2D6E5B1F-8A4C-4B71-9E3A-000000000002}" type="slidenum">
+              <a:rPr lang="he-IL" sz="1200"/>
+              <a:t>2</a:t>
+            </a:fld>
+          </a:p>
+        </p:txBody>
+      </p:sp>
     </p:spTree>
     <p:extLst>
       <p:ext uri="{BB962C8B-B14F-4D97-AF65-F5344CB8AC3E}">
@@ -5987,7 +6563,7 @@
               <a:rPr lang="he-IL" sz="2200" dirty="0">
                 <a:cs typeface="+mn-cs"/>
               </a:rPr>
-              <a:t>שאלת המחקר שהנחתה את הפרויקט היא </a:t>
+              <a:t>שאלת המחקר היא </a:t>
             </a:r>
             <a:r>
               <a:rPr lang="he-IL" sz="2200" b="1" dirty="0">
@@ -6002,7 +6578,7 @@
               <a:rPr lang="he-IL" sz="2200" dirty="0">
                 <a:cs typeface="+mn-cs"/>
               </a:rPr>
-              <a:t>. השאלה נוסחה כשאלה פתוחה ולא כהשערה, משום שהמחקר איכותני ומטרתו לתאר מנגנון ולא לאמוד את שכיחותו. ממנה נגזרות שלוש מטרות. הראשונה היא לזהות את החסמים ואת המאיצים כפי שהנשים עצמן מנסחות אותם, ולא כפי שהם מסווגים בספרות. השנייה היא לבחון כיצד הגורמים פועלים זה על זה, מתוך ההנחה שאישה אינה חווה רשימה של חסמים נפרדים אלא מכשול אחד מורכב. השלישית היא לגזור מן הממצאים המלצות יישומיות לקופות החולים ולמשרד הבריאות, שכן פרויקט הגמר הוא מסמך ניהולי ולא מחקרי בלבד. הבחירה לראיין נשים ולא רק אנשי מקצוע נובעת מן העמדה ש</a:t>
+              <a:t>. מאחר שהמחקר איכותני ומטרתו לתאר מנגנון ולא לאמוד את שכיחותו, נוסחה שאלה פתוחה ולא הוצבו השערות מחקר. משאלה זו נגזרות שלוש מטרות. הראשונה היא זיהוי החסמים והמאיצים כפי שהם מנוסחים על ידי הנשים עצמן, ולא כפי שהם מסווגים מראש בספרות. השנייה היא בחינת יחסי הגומלין בין הגורמים, מתוך ההנחה כי הם נחווים כמכשול מצטבר אחד ולא כרשימה של חסמים נפרדים. השלישית היא גזירת המלצות יישומיות לקופות החולים ולמשרד הבריאות, בהתאם לאופיו הפרקטי של פרויקט הגמר. הבחירה באוכלוסיית הנשים כמושא הראיון, ולא באנשי מקצוע בלבד, נשענת על ההנחה כי </a:t>
             </a:r>
             <a:r>
               <a:rPr lang="he-IL" sz="2200" b="1" dirty="0">
@@ -6011,13 +6587,13 @@
                 </a:solidFill>
                 <a:cs typeface="+mn-cs"/>
               </a:rPr>
-              <a:t>ההחלטה שלא ללכת לבדיקה היא החלטה בעלת היגיון פנימי</a:t>
+              <a:t>הימנעות מבדיקה היא התנהגות בעלת היגיון פנימי הניתן לתיאור ולניתוח</a:t>
             </a:r>
             <a:r>
               <a:rPr lang="he-IL" sz="2200" dirty="0">
                 <a:cs typeface="+mn-cs"/>
               </a:rPr>
-              <a:t>, גם כשהיא נראית מבחוץ כהזנחה.</a:t>
+              <a:t>.</a:t>
             </a:r>
           </a:p>
         </p:txBody>
@@ -6058,6 +6634,29 @@
           </a:prstGeom>
         </p:spPr>
       </p:pic>
+      <p:sp>
+        <p:nvSpPr>
+          <p:cNvPr id="31" name="מציין מיקום של מספר שקופית"/>
+          <p:cNvSpPr>
+            <a:spLocks noGrp="1"/>
+          </p:cNvSpPr>
+          <p:nvPr>
+            <p:ph type="sldNum" sz="quarter" idx="12"/>
+          </p:nvPr>
+        </p:nvSpPr>
+        <p:spPr/>
+        <p:txBody>
+          <a:bodyPr/>
+          <a:lstStyle/>
+          <a:p>
+            <a:pPr algn="l" rtl="0"/>
+            <a:fld id="{2D6E5B1F-8A4C-4B71-9E3A-000000000003}" type="slidenum">
+              <a:rPr lang="he-IL" sz="1200"/>
+              <a:t>3</a:t>
+            </a:fld>
+          </a:p>
+        </p:txBody>
+      </p:sp>
     </p:spTree>
     <p:extLst>
       <p:ext uri="{BB962C8B-B14F-4D97-AF65-F5344CB8AC3E}">
@@ -6169,7 +6768,7 @@
               <a:rPr lang="he-IL" sz="2200" dirty="0">
                 <a:cs typeface="+mn-cs"/>
               </a:rPr>
-              <a:t>הספרות מצביעה בעקביות על שלוש משפחות של חסמים. במישור התרבותי והרגשי חוזרים הבושה והמבוכה מחשיפת הגוף, החשש מפני רכילות ותיוג חברתי, החשש לפגוע במעמד המשפחה ובסיכויי הנישואין של בנותיה, והפחד מן המחלה ומתוצאות הבדיקה (Cohen &amp; Azaiza, 2006). במישור האמוני מתועדות תפיסות פטליסטיות הרואות במחלה גורל שאין לשנותו, והן נמצאו כמנבאות מובהקות של אי-היענות (Azaiza et al., 2010). במישור המבני והמערכתי מזוהים מרחק ותלות בהסעה, היעדר בודקת אישה, פערי שפה וזימונים שאינם מגיעים או שאינם מובנים (מורן ואבו עבייד, 2018). מנגד, מחקרים עדכניים מלמדים כי </a:t>
+              <a:t>הספרות המחקרית מזהה שלוש משפחות של חסמים להיענות. במישור התרבותי והרגשי מתועדים הבושה והמבוכה הכרוכות בחשיפת הגוף, החשש מפני תיוג חברתי ורכילות, החשש לפגיעה במעמד המשפחה ובסיכויי הנישואין של בנותיה, והפחד מן המחלה ומתוצאות הבדיקה (Cohen &amp; Azaiza, 2006). במישור האמוני מתועדות תפיסות פטליסטיות הרואות במחלה גורל שאין לשנותו, ואלה נמצאו כמנבאות מובהקות של אי-היענות (Azaiza et al., 2010). במישור המבני והמערכתי מזוהים מרחק ותלות בהסעה, היעדר בודקת אישה, פערי שפה וזימונים שאינם מגיעים או שאינם מובנים (מורן ואבו עבייד, 2018). לצד אלה עולה מן הספרות העדכנית כי </a:t>
             </a:r>
             <a:r>
               <a:rPr lang="he-IL" sz="2200" b="1" dirty="0">
@@ -6178,13 +6777,13 @@
                 </a:solidFill>
                 <a:cs typeface="+mn-cs"/>
               </a:rPr>
-              <a:t>הפערים בתמותה בין הקבוצות מצטמצמים כמעט לחלוטין לאחר תקנון למשתנים חברתיים-כלכליים</a:t>
+              <a:t>הפערים בתמותה בין הקבוצות מצטמצמים ואינם נותרים מובהקים לאחר תקנון למשתנים סוציו-דמוגרפיים</a:t>
             </a:r>
             <a:r>
               <a:rPr lang="he-IL" sz="2200" dirty="0">
                 <a:cs typeface="+mn-cs"/>
               </a:rPr>
-              <a:t>, ממצא הממקם את שורש הבעיה, וממילא את הפתרון, בתחום המדיניות הציבורית ולא בתחום הביולוגי או התרבותי הבלתי ניתן לשינוי (Pinchas-Mizrachi &amp; Bouhnik, 2024).</a:t>
+              <a:t>, ממצא הממקם את מקורם של הפערים בתחום המדיניות הציבורית ולא בתחום הביולוגי (Pinchas-Mizrachi &amp; Bouhnik, 2024).</a:t>
             </a:r>
           </a:p>
         </p:txBody>
@@ -6225,6 +6824,29 @@
           </a:prstGeom>
         </p:spPr>
       </p:pic>
+      <p:sp>
+        <p:nvSpPr>
+          <p:cNvPr id="31" name="מציין מיקום של מספר שקופית"/>
+          <p:cNvSpPr>
+            <a:spLocks noGrp="1"/>
+          </p:cNvSpPr>
+          <p:nvPr>
+            <p:ph type="sldNum" sz="quarter" idx="12"/>
+          </p:nvPr>
+        </p:nvSpPr>
+        <p:spPr/>
+        <p:txBody>
+          <a:bodyPr/>
+          <a:lstStyle/>
+          <a:p>
+            <a:pPr algn="l" rtl="0"/>
+            <a:fld id="{2D6E5B1F-8A4C-4B71-9E3A-000000000004}" type="slidenum">
+              <a:rPr lang="he-IL" sz="1200"/>
+              <a:t>4</a:t>
+            </a:fld>
+          </a:p>
+        </p:txBody>
+      </p:sp>
     </p:spTree>
     <p:extLst>
       <p:ext uri="{BB962C8B-B14F-4D97-AF65-F5344CB8AC3E}">
@@ -6336,7 +6958,7 @@
               <a:rPr lang="he-IL" sz="2200" dirty="0">
                 <a:cs typeface="+mn-cs"/>
               </a:rPr>
-              <a:t>לצד החסמים מזהה הספרות גורמים מאיצים, ובראשם </a:t>
+              <a:t>לצד החסמים מזוהים בספרות גורמים מאיצים, ובראשם </a:t>
             </a:r>
             <a:r>
               <a:rPr lang="he-IL" sz="2200" b="1" dirty="0">
@@ -6345,13 +6967,13 @@
                 </a:solidFill>
                 <a:cs typeface="+mn-cs"/>
               </a:rPr>
-              <a:t>המלצה אקטיבית של איש מקצוע רפואי</a:t>
+              <a:t>המלצה אקטיבית מצד ספק שירותי הבריאות</a:t>
             </a:r>
             <a:r>
               <a:rPr lang="he-IL" sz="2200" dirty="0">
                 <a:cs typeface="+mn-cs"/>
               </a:rPr>
-              <a:t>, שנמצאה כמנבא המובהק והעקבי ביותר לביצוע הבדיקה, לצד זימון יזום ממוחשב, מכתבי הזמנה ותזכורות (Freund et al., 2019). התערבויות מותאמות-תרבות, המועברות בשפת הנשים ובאמצעות דמויות מפתח מן הקהילה ובהן נשים שהחלימו מן המחלה, נמצאו יעילות יותר מקמפיינים חינוכיים כלליים (Cohen &amp; Azaiza, 2008), וכלים לוגיסטיים כמו ניידת ממוגרפיה הוכיחו יכולת לצמצם פערים באופן ממשי. מה שנותר פתוח הוא </a:t>
+              <a:t>, שנמצאה כמנבא המובהק והעקבי ביותר לביצוע הבדיקה, לצד זימון יזום ממוחשב, מכתבי הזמנה ותזכורות (Freund et al., 2019). התערבויות מותאמות-תרבות, המועברות בשפת הנשים ובאמצעות דמויות מפתח מן הקהילה ובהן נשים ששרדו את המחלה, נמצאו אפקטיביות יותר מקמפיינים חינוכיים גנריים (Cohen &amp; Azaiza, 2008). הסוגיה שנותרה פתוחה היא </a:t>
             </a:r>
             <a:r>
               <a:rPr lang="he-IL" sz="2200" b="1" dirty="0">
@@ -6366,7 +6988,7 @@
               <a:rPr lang="he-IL" sz="2200" dirty="0">
                 <a:cs typeface="+mn-cs"/>
               </a:rPr>
-              <a:t>: רוב הנשים הערביות מעל גיל חמישים כבר עברו ממוגרפיה לפחות פעם אחת, ובכל זאת ההיענות ללוח הזמנים המומלץ נותרת נמוכה (Cohen &amp; Azaiza, 2006). מאחר שרוב המחקרים בתחום כמותיים, הם מתעדים את שכיחות החסמים אך אינם מתארים כיצד הם פועלים בחיי היומיום, וזהו החלל שהפרויקט הנוכחי מבקש למלא.</a:t>
+              <a:t>: רוב הנשים הערביות מעל גיל חמישים כבר עברו ממוגרפיה לפחות פעם אחת, ואף על פי כן ההיענות ללוח הזמנים המומלץ נותרת נמוכה (Cohen &amp; Azaiza, 2006). מאחר שמרבית המחקרים בתחום כמותיים, הם מתעדים את שכיחות החסמים ואת עוצמת הקשר שלהם להיענות, אך אינם מתארים את אופן פעולתם בפועל, וזהו החלל שהפרויקט הנוכחי מבקש למלא.</a:t>
             </a:r>
           </a:p>
         </p:txBody>
@@ -6407,6 +7029,29 @@
           </a:prstGeom>
         </p:spPr>
       </p:pic>
+      <p:sp>
+        <p:nvSpPr>
+          <p:cNvPr id="31" name="מציין מיקום של מספר שקופית"/>
+          <p:cNvSpPr>
+            <a:spLocks noGrp="1"/>
+          </p:cNvSpPr>
+          <p:nvPr>
+            <p:ph type="sldNum" sz="quarter" idx="12"/>
+          </p:nvPr>
+        </p:nvSpPr>
+        <p:spPr/>
+        <p:txBody>
+          <a:bodyPr/>
+          <a:lstStyle/>
+          <a:p>
+            <a:pPr algn="l" rtl="0"/>
+            <a:fld id="{2D6E5B1F-8A4C-4B71-9E3A-000000000005}" type="slidenum">
+              <a:rPr lang="he-IL" sz="1200"/>
+              <a:t>5</a:t>
+            </a:fld>
+          </a:p>
+        </p:txBody>
+      </p:sp>
     </p:spTree>
     <p:extLst>
       <p:ext uri="{BB962C8B-B14F-4D97-AF65-F5344CB8AC3E}">
@@ -6518,7 +7163,7 @@
               <a:rPr lang="he-IL" sz="2200" dirty="0">
                 <a:cs typeface="+mn-cs"/>
               </a:rPr>
-              <a:t>המסגרת המרכזית בתחום היא מודל האמונות הבריאותיות, המסביר התנהגות מונעת באמצעות תפיסת הפגיעוּת האישית, תפיסת חומרת המחלה, התועלות הנתפסות מן הבדיקה והחסמים הנתפסים בפניה, לצד רמזים לפעולה ותחושת מסוגלות (סטרן, 2007). לצידו משמשים מודל שלבי השינוי, המתאים התערבות לשלב שבו נמצאת האישה, ותיאוריית הפעולה המנומקת, הרואה בכוונה ההתנהגותית תוצר של עמדות אישיות ושל נורמות חברתיות נתפסות, שנמצאו משמעותיות במיוחד בקרב נשים ערביות מוסלמיות בישראל (Soskolne et al., 2007). מגבלתם המשותפת היא שפותחו בהקשר מערבי-אינדיבידואליסטי ואינם לוכדים במלואם משתנים כמו בושה, מבנה משפחה מורחבת ותפיסות דתיות. לפיכך אומצה כאן גם </a:t>
+              <a:t>המסגרת התיאורטית המרכזית בתחום היא מודל האמונות הבריאותיות, המסביר התנהגות מונעת באמצעות תפיסת הפגיעוּת האישית, תפיסת חומרת המחלה, התועלות הנתפסות מן הבדיקה והחסמים הנתפסים בפניה, לצד רמזים לפעולה ותחושת מסוגלות עצמית (סטרן, 2007). לצידו משמשים מודל שלבי השינוי, המאפשר התאמת ההתערבות לשלב שבו מצויה האישה, ותיאוריית הפעולה המנומקת, הרואה בכוונה ההתנהגותית תוצר של עמדות אישיות ושל נורמות חברתיות נתפסות, שנמצאו בעלות כוח הסבר ניכר בקרב נשים ערביות מוסלמיות בישראל (Soskolne et al., 2007). מגבלתם המשותפת של מודלים אלה היא שפותחו בהקשר מערבי-אינדיבידואליסטי ואינם לוכדים במלואם משתנים כגון בושה, מבנה משפחה מורחבת ותפיסות דתיות. לפיכך אומצה כאן גם </a:t>
             </a:r>
             <a:r>
               <a:rPr lang="he-IL" sz="2200" b="1" dirty="0">
@@ -6533,7 +7178,7 @@
               <a:rPr lang="he-IL" sz="2200" dirty="0">
                 <a:cs typeface="+mn-cs"/>
               </a:rPr>
-              <a:t>, הבוחנת את ההתנהגות בארבע רמות המשפיעות זו על זו, האישית, הבין-אישית, הקהילתית והמערכתית, ומדגישה כי התערבות ברמה אחת בלבד אינה מספיקה (Alatawneh et al., 2024). המודל שגובש בפרויקט נגזר מגישה זו ומוצג בפרק הממצאים.</a:t>
+              <a:t>, הבוחנת את ההתנהגות בארבע רמות המשפיעות זו על זו, האישית, הבין-אישית, הקהילתית והמערכתית, ומדגישה כי התערבות ברמה אחת בלבד אינה מספקת (Alatawneh et al., 2024).</a:t>
             </a:r>
           </a:p>
         </p:txBody>
@@ -6574,6 +7219,29 @@
           </a:prstGeom>
         </p:spPr>
       </p:pic>
+      <p:sp>
+        <p:nvSpPr>
+          <p:cNvPr id="31" name="מציין מיקום של מספר שקופית"/>
+          <p:cNvSpPr>
+            <a:spLocks noGrp="1"/>
+          </p:cNvSpPr>
+          <p:nvPr>
+            <p:ph type="sldNum" sz="quarter" idx="12"/>
+          </p:nvPr>
+        </p:nvSpPr>
+        <p:spPr/>
+        <p:txBody>
+          <a:bodyPr/>
+          <a:lstStyle/>
+          <a:p>
+            <a:pPr algn="l" rtl="0"/>
+            <a:fld id="{2D6E5B1F-8A4C-4B71-9E3A-000000000006}" type="slidenum">
+              <a:rPr lang="he-IL" sz="1200"/>
+              <a:t>6</a:t>
+            </a:fld>
+          </a:p>
+        </p:txBody>
+      </p:sp>
     </p:spTree>
     <p:extLst>
       <p:ext uri="{BB962C8B-B14F-4D97-AF65-F5344CB8AC3E}">
@@ -6685,7 +7353,7 @@
               <a:rPr lang="he-IL" sz="2200" dirty="0">
                 <a:cs typeface="+mn-cs"/>
               </a:rPr>
-              <a:t>המחקר איכותני ומבוסס על ראיונות עומק חצי מובנים. הבחירה בשיטה נגזרת מאופייה של שאלת המחקר, שכן חסמים כמו בושה, פחד מלדעת ותפיסות של גורל אינם מתנסחים בקלות בסולם ליקרט והם עולים לרוב באמצע סיפור על משהו אחר. אוכלוסיית המחקר היא נשים בגיל הרלוונטי לבדיקה או בסמוך לו, ובמדגם נכללו </a:t>
+              <a:t>המחקר הוא מחקר איכותני המבוסס על ראיונות עומק חצי מובנים. בחירת השיטה נגזרת מאופייה של שאלת המחקר, שכן מושגים כגון בושה, חשש מאבחנה ותפיסות של גורל אינם ניתנים למדידה מהימנה בכלי סגור, והם עולים לרוב באופן עקיף ובלתי מתוכנן במהלך הראיון. אוכלוסיית המחקר מוגדרת כנשים בגיל הרלוונטי לבדיקה או בסמוך לו, ובמדגם נכללו </a:t>
             </a:r>
             <a:r>
               <a:rPr lang="he-IL" sz="2200" b="1" dirty="0">
@@ -6700,7 +7368,7 @@
               <a:rPr lang="he-IL" sz="2200" dirty="0">
                 <a:cs typeface="+mn-cs"/>
               </a:rPr>
-              <a:t> שנבחרו בדגימה מכוונת ובשיטת כדור השלג. המדגם נבנה מתוך הקפדה על שונוּת פנימית, ולכן הוא כולל נשים מוסלמיות, נוצרייה, דרוזית ובדואיות מיישובים ערביים, מערים מעורבות ומן הנגב, ברמות השכלה הנעות משמונה שנות לימוד ועד תואר אקדמי, ולצידן אישה יוצאת אתיופיה שנכללה כדי לאפשר הבחנה בין חסם תרבותי לחסם של שפה ונגישות. כלי המחקר הוא מדריך ראיון בן שש עשרה שאלות קבועות, והנתונים נאספו בהקלטה ובתמלול מלא של כל ראיון.</a:t>
+              <a:t> שנבחרו בדגימה מכוונת ובשיטת כדור השלג. המדגם נבנה תוך הקפדה על שונוּת פנימית, והוא כולל נשים מוסלמיות, נוצרייה, דרוזית ובדואיות מיישובים ערביים, מערים מעורבות ומן הנגב, ברמות השכלה הנעות משמונה שנות לימוד ועד תואר אקדמי, ולצידן אישה יוצאת אתיופיה שנכללה לצורך הבחנה בין חסם תרבותי לבין חסם של שפה ונגישות בקבוצת מיעוט אחרת.</a:t>
             </a:r>
           </a:p>
         </p:txBody>
@@ -6741,6 +7409,29 @@
           </a:prstGeom>
         </p:spPr>
       </p:pic>
+      <p:sp>
+        <p:nvSpPr>
+          <p:cNvPr id="31" name="מציין מיקום של מספר שקופית"/>
+          <p:cNvSpPr>
+            <a:spLocks noGrp="1"/>
+          </p:cNvSpPr>
+          <p:nvPr>
+            <p:ph type="sldNum" sz="quarter" idx="12"/>
+          </p:nvPr>
+        </p:nvSpPr>
+        <p:spPr/>
+        <p:txBody>
+          <a:bodyPr/>
+          <a:lstStyle/>
+          <a:p>
+            <a:pPr algn="l" rtl="0"/>
+            <a:fld id="{2D6E5B1F-8A4C-4B71-9E3A-000000000007}" type="slidenum">
+              <a:rPr lang="he-IL" sz="1200"/>
+              <a:t>7</a:t>
+            </a:fld>
+          </a:p>
+        </p:txBody>
+      </p:sp>
     </p:spTree>
     <p:extLst>
       <p:ext uri="{BB962C8B-B14F-4D97-AF65-F5344CB8AC3E}">
@@ -10714,6 +11405,29 @@
           </a:graphicData>
         </a:graphic>
       </p:graphicFrame>
+      <p:sp>
+        <p:nvSpPr>
+          <p:cNvPr id="31" name="מציין מיקום של מספר שקופית"/>
+          <p:cNvSpPr>
+            <a:spLocks noGrp="1"/>
+          </p:cNvSpPr>
+          <p:nvPr>
+            <p:ph type="sldNum" sz="quarter" idx="12"/>
+          </p:nvPr>
+        </p:nvSpPr>
+        <p:spPr/>
+        <p:txBody>
+          <a:bodyPr/>
+          <a:lstStyle/>
+          <a:p>
+            <a:pPr algn="l" rtl="0"/>
+            <a:fld id="{2D6E5B1F-8A4C-4B71-9E3A-000000000008}" type="slidenum">
+              <a:rPr lang="he-IL" sz="1200"/>
+              <a:t>8</a:t>
+            </a:fld>
+          </a:p>
+        </p:txBody>
+      </p:sp>
     </p:spTree>
     <p:extLst>
       <p:ext uri="{BB962C8B-B14F-4D97-AF65-F5344CB8AC3E}">
@@ -10825,7 +11539,7 @@
               <a:rPr lang="he-IL" sz="2200" dirty="0">
                 <a:cs typeface="+mn-cs"/>
               </a:rPr>
-              <a:t>מדריך הראיון כולל שש עשרה שאלות פתוחות ובהן שאלת פתיחה כללית שנועדה ליצור היכרות לפני המעבר לנושא הרגיש, והוא הועבר בנוסח זהה ובסדר זהה בכל שנים עשר הראיונות. השאלות נבנו על בסיס הממדים שעלו מסקירת הספרות, כך שכל אשכול מכוון לתחום מוכר של חסמים או מאיצים: שאלות הפתיחה עוסקות בידע ובחוויית הבדיקה בפועל, שאלות האמצע בפחד, בצניעות, במגדר הבודק ובתיוג החברתי, ולאחריהן שאלות על המשפחה המורחבת, על הממד הדתי, על ההתנהלות מול הקופה ועל המלצת איש המקצוע. שתי שאלות נוסחו מחדש לאחר ראיון הפיילוט משום שנמצאו מכוונות מדי לתשובה שלילית. הראיונות נמשכו בין 32 ל-45 דקות, שישה נערכו בעברית, חמישה בערבית ואחד באמהרית, וכל אחת משלוש חברות הצוות ערכה ארבעה ראיונות. הניתוח נעשה ב</a:t>
+              <a:t>כלי המחקר הוא מדריך ראיון חצי מובנה הכולל שש עשרה שאלות פתוחות, ובהן שאלת פתיחה כללית שנועדה ליצור היכרות בטרם המעבר לנושא הרגיש. המדריך הועבר בנוסח זהה ובסדר זהה בכל שנים עשר הראיונות. השאלות נגזרו מן הממדים שעלו בסקירת הספרות: האשכול הראשון עוסק בידע ובחוויית הבדיקה בפועל, השני בפחד, בצניעות, במגדר מבצע הבדיקה ובתיוג החברתי, והשלישי במשפחה המורחבת, בממד הדתי, בהתנהלות מול קופת החולים ובהמלצת ספק השירות. שתי שאלות נוסחו מחדש בעקבות ראיון פיילוט, משום שנמצאו מוטות לכיוון תשובה שלילית. הראיונות נמשכו בין 32 ל-45 דקות, הוקלטו בהסכמה ותומללו במלואם, ונותחו ב</a:t>
             </a:r>
             <a:r>
               <a:rPr lang="he-IL" sz="2200" b="1" dirty="0">
@@ -10840,7 +11554,7 @@
               <a:rPr lang="he-IL" sz="2200" dirty="0">
                 <a:cs typeface="+mn-cs"/>
               </a:rPr>
-              <a:t>, מקריאה חוזרת ללא סימון ועד בחירת ציטוטים תומכים, לרבות ציטוטים הסותרים את התמה. כל המשתתפות נתנו הסכמה מדעת בעל פה, השמות בדויים וכל פרט מזהה טושטש.</a:t>
+              <a:t>. כל המשתתפות נתנו הסכמה מדעת, השמות בדויים וכל פרט מזהה טושטש.</a:t>
             </a:r>
           </a:p>
         </p:txBody>
@@ -10881,6 +11595,29 @@
           </a:prstGeom>
         </p:spPr>
       </p:pic>
+      <p:sp>
+        <p:nvSpPr>
+          <p:cNvPr id="31" name="מציין מיקום של מספר שקופית"/>
+          <p:cNvSpPr>
+            <a:spLocks noGrp="1"/>
+          </p:cNvSpPr>
+          <p:nvPr>
+            <p:ph type="sldNum" sz="quarter" idx="12"/>
+          </p:nvPr>
+        </p:nvSpPr>
+        <p:spPr/>
+        <p:txBody>
+          <a:bodyPr/>
+          <a:lstStyle/>
+          <a:p>
+            <a:pPr algn="l" rtl="0"/>
+            <a:fld id="{2D6E5B1F-8A4C-4B71-9E3A-000000000009}" type="slidenum">
+              <a:rPr lang="he-IL" sz="1200"/>
+              <a:t>9</a:t>
+            </a:fld>
+          </a:p>
+        </p:txBody>
+      </p:sp>
     </p:spTree>
     <p:extLst>
       <p:ext uri="{BB962C8B-B14F-4D97-AF65-F5344CB8AC3E}">

</xml_diff>

<commit_message>
Set the recommendations out as a numbered list
The six recommendations were a single dense paragraph on the slide and a
bullet run in the chapter, which made them hard to hold onto and hard to
refer back to in a discussion. They are now numbered one to six under
two headings, the clinic level and the health fund and ministry level,
with the recommendation itself in bold and the detail following it.

The chapter keeps the fuller wording with the measurable target on the
first item; the slide carries the short form. Two items whose detail
read as a fragment after the bold lead-in were rewritten as full
sentences.

The conclusions chapter stays at about 1.2 pages and the body at about
23.8, both inside the handbook's limits. Layout and schema checks pass.

Co-Authored-By: Claude Fable 5 <noreply@anthropic.com>
Claude-Session: https://claude.ai/code/session_01Aebwgiv2BDsZYZ7oiMCAJ9
</commit_message>
<xml_diff>
--- a/seminar-interviews/מצגת-פרויקט-גמר-תבנית-המכללה.pptx
+++ b/seminar-interviews/מצגת-פרויקט-גמר-תבנית-המכללה.pptx
@@ -610,7 +610,7 @@
             <a:pPr algn="r" rtl="1"/>
             <a:r>
               <a:rPr lang="he-IL" sz="1200" dirty="0"/>
-              <a:t>לקשור כל המלצה לתמה שממנה נגזרה, ולהבחין בין רמת המרפאה לרמת המדיניות.</a:t>
+              <a:t>לעבור על שש ההמלצות לפי מספרן, ולקשור כל אחת לתמה שממנה נגזרה. להבחין בין רמת המרפאה לרמת המדיניות.</a:t>
             </a:r>
           </a:p>
         </p:txBody>
@@ -5836,18 +5836,18 @@
                 <a:spcPct val="100000"/>
               </a:lnSpc>
               <a:spcBef>
-                <a:spcPts val="600"/>
+                <a:spcPts val="0"/>
               </a:spcBef>
               <a:buNone/>
             </a:pPr>
             <a:r>
-              <a:rPr lang="he-IL" sz="2200" dirty="0">
+              <a:rPr lang="he-IL" sz="1700" dirty="0">
                 <a:cs typeface="+mn-cs"/>
               </a:rPr>
-              <a:t>ההמלצות נגזרות מן הממצאים, ומשותף לכולן שאין הן מכוונות לשינוי אמונותיהן של הנשים אלא </a:t>
-            </a:r>
-            <a:r>
-              <a:rPr lang="he-IL" sz="2200" b="1" dirty="0">
+              <a:t>ההמלצות נגזרות מן הממצאים, ואינן מכוונות לשינוי אמונותיהן של הנשים אלא </a:t>
+            </a:r>
+            <a:r>
+              <a:rPr lang="he-IL" sz="1700" b="1" dirty="0">
                 <a:solidFill>
                   <a:srgbClr val="1F3864"/>
                 </a:solidFill>
@@ -5856,10 +5856,224 @@
               <a:t>להסרת הגורמים החוצצים בין הכוונה לבין הפעולה</a:t>
             </a:r>
             <a:r>
-              <a:rPr lang="he-IL" sz="2200" dirty="0">
+              <a:rPr lang="he-IL" sz="1700" dirty="0">
                 <a:cs typeface="+mn-cs"/>
               </a:rPr>
-              <a:t>. ברמת המרפאה, ובעלות נמוכה יחסית, מוצע להעמיד רכזת זימונים דוברת ערבית שתפעל בפנייה טלפונית יזומה ולא במשלוח מכתבים, ולמדוד את שיעור ההמרה משיחה לתור שנקבע בפועל; לשלב במערכת הממוחשבת התראה לרופא המשפחה בפתיחת ביקור של אישה בגיל הזכאות שאיחרה בבדיקה, כך שההמלצה תינתן במפגש הקליני; ולהרחיב את פריסת התורים לשעות אחר הצהריים ולימי שישי לצד אישור היעדרות מעבודה. ברמת הקופה ומשרד הבריאות מוצע להפעיל את ניידת הממוגרפיה על פי לוח שנתי קבוע ובמיקום דיסקרטי, להכשיר נשים מקומיות שנבדקו להנחיית מפגשים בהיקף מצומצם, ולבחון הרחבת הזימון היזום לגילאי 45 עד 49 בקהילות שבהן חציון גיל האבחון צעיר.</a:t>
+              <a:t>.</a:t>
+            </a:r>
+          </a:p>
+          <a:p>
+            <a:pPr marL="0" indent="0" algn="r" rtl="1">
+              <a:lnSpc>
+                <a:spcPct val="100000"/>
+              </a:lnSpc>
+              <a:spcBef>
+                <a:spcPts val="500"/>
+              </a:spcBef>
+              <a:buNone/>
+            </a:pPr>
+            <a:r>
+              <a:rPr lang="he-IL" sz="1800" b="1" dirty="0">
+                <a:solidFill>
+                  <a:srgbClr val="1F3864"/>
+                </a:solidFill>
+                <a:cs typeface="+mn-cs"/>
+              </a:rPr>
+              <a:t>ברמת המרפאה, בעלות נמוכה יחסית</a:t>
+            </a:r>
+          </a:p>
+          <a:p>
+            <a:pPr marL="514350" indent="-514350" algn="just" rtl="1">
+              <a:lnSpc>
+                <a:spcPct val="100000"/>
+              </a:lnSpc>
+              <a:spcBef>
+                <a:spcPts val="300"/>
+              </a:spcBef>
+              <a:buNone/>
+            </a:pPr>
+            <a:r>
+              <a:rPr lang="he-IL" sz="1700" b="1" dirty="0">
+                <a:cs typeface="+mn-cs"/>
+              </a:rPr>
+              <a:t>1-  </a:t>
+            </a:r>
+            <a:r>
+              <a:rPr lang="he-IL" sz="1700" b="1" dirty="0">
+                <a:cs typeface="+mn-cs"/>
+              </a:rPr>
+              <a:t>רכזת זימונים דוברת ערבית שמטלפנת ואינה שולחת מכתבים,</a:t>
+            </a:r>
+            <a:r>
+              <a:rPr lang="he-IL" sz="1700" dirty="0">
+                <a:cs typeface="+mn-cs"/>
+              </a:rPr>
+              <a:t> תוך מדידת שיעור ההמרה משיחה לתור שנקבע בפועל.</a:t>
+            </a:r>
+          </a:p>
+          <a:p>
+            <a:pPr marL="514350" indent="-514350" algn="just" rtl="1">
+              <a:lnSpc>
+                <a:spcPct val="100000"/>
+              </a:lnSpc>
+              <a:spcBef>
+                <a:spcPts val="300"/>
+              </a:spcBef>
+              <a:buNone/>
+            </a:pPr>
+            <a:r>
+              <a:rPr lang="he-IL" sz="1700" b="1" dirty="0">
+                <a:cs typeface="+mn-cs"/>
+              </a:rPr>
+              <a:t>2-  </a:t>
+            </a:r>
+            <a:r>
+              <a:rPr lang="he-IL" sz="1700" b="1" dirty="0">
+                <a:cs typeface="+mn-cs"/>
+              </a:rPr>
+              <a:t>התראה לרופא המשפחה בפתיחת ביקור של אישה שאיחרה בבדיקה,</a:t>
+            </a:r>
+            <a:r>
+              <a:rPr lang="he-IL" sz="1700" dirty="0">
+                <a:cs typeface="+mn-cs"/>
+              </a:rPr>
+              <a:t> כך שההמלצה תינתן ביוזמת המטפל ולא ביוזמת האישה.</a:t>
+            </a:r>
+          </a:p>
+          <a:p>
+            <a:pPr marL="514350" indent="-514350" algn="just" rtl="1">
+              <a:lnSpc>
+                <a:spcPct val="100000"/>
+              </a:lnSpc>
+              <a:spcBef>
+                <a:spcPts val="300"/>
+              </a:spcBef>
+              <a:buNone/>
+            </a:pPr>
+            <a:r>
+              <a:rPr lang="he-IL" sz="1700" b="1" dirty="0">
+                <a:cs typeface="+mn-cs"/>
+              </a:rPr>
+              <a:t>3-  </a:t>
+            </a:r>
+            <a:r>
+              <a:rPr lang="he-IL" sz="1700" b="1" dirty="0">
+                <a:cs typeface="+mn-cs"/>
+              </a:rPr>
+              <a:t>פריסת תורים באחר הצהריים ובימי שישי,</a:t>
+            </a:r>
+            <a:r>
+              <a:rPr lang="he-IL" sz="1700" dirty="0">
+                <a:cs typeface="+mn-cs"/>
+              </a:rPr>
+              <a:t> לצד אישור היעדרות מעבודה לאישה שהגיעה לבדיקה.</a:t>
+            </a:r>
+          </a:p>
+          <a:p>
+            <a:pPr marL="0" indent="0" algn="r" rtl="1">
+              <a:lnSpc>
+                <a:spcPct val="100000"/>
+              </a:lnSpc>
+              <a:spcBef>
+                <a:spcPts val="500"/>
+              </a:spcBef>
+              <a:buNone/>
+            </a:pPr>
+            <a:r>
+              <a:rPr lang="he-IL" sz="1800" b="1" dirty="0">
+                <a:solidFill>
+                  <a:srgbClr val="1F3864"/>
+                </a:solidFill>
+                <a:cs typeface="+mn-cs"/>
+              </a:rPr>
+              <a:t>ברמת הקופה ומשרד הבריאות</a:t>
+            </a:r>
+          </a:p>
+          <a:p>
+            <a:pPr marL="514350" indent="-514350" algn="just" rtl="1">
+              <a:lnSpc>
+                <a:spcPct val="100000"/>
+              </a:lnSpc>
+              <a:spcBef>
+                <a:spcPts val="300"/>
+              </a:spcBef>
+              <a:buNone/>
+            </a:pPr>
+            <a:r>
+              <a:rPr lang="he-IL" sz="1700" b="1" dirty="0">
+                <a:cs typeface="+mn-cs"/>
+              </a:rPr>
+              <a:t>4-  </a:t>
+            </a:r>
+            <a:r>
+              <a:rPr lang="he-IL" sz="1700" b="1" dirty="0">
+                <a:cs typeface="+mn-cs"/>
+              </a:rPr>
+              <a:t>ניידת ממוגרפיה בלוח שנתי קבוע ובמיקום דיסקרטי,</a:t>
+            </a:r>
+            <a:r>
+              <a:rPr lang="he-IL" sz="1700" dirty="0">
+                <a:cs typeface="+mn-cs"/>
+              </a:rPr>
+              <a:t> ולא כאירוע חד-פעמי בחזית המרפאה.</a:t>
+            </a:r>
+          </a:p>
+          <a:p>
+            <a:pPr marL="514350" indent="-514350" algn="just" rtl="1">
+              <a:lnSpc>
+                <a:spcPct val="100000"/>
+              </a:lnSpc>
+              <a:spcBef>
+                <a:spcPts val="300"/>
+              </a:spcBef>
+              <a:buNone/>
+            </a:pPr>
+            <a:r>
+              <a:rPr lang="he-IL" sz="1700" b="1" dirty="0">
+                <a:cs typeface="+mn-cs"/>
+              </a:rPr>
+              <a:t>5-  </a:t>
+            </a:r>
+            <a:r>
+              <a:rPr lang="he-IL" sz="1700" b="1" dirty="0">
+                <a:cs typeface="+mn-cs"/>
+              </a:rPr>
+              <a:t>מפגשים ביתיים בהנחיית נשים מקומיות שנבדקו,</a:t>
+            </a:r>
+            <a:r>
+              <a:rPr lang="he-IL" sz="1700" dirty="0">
+                <a:cs typeface="+mn-cs"/>
+              </a:rPr>
+              <a:t> במסגרת קטנה ומוכרת במקום הרצאות פומביות.</a:t>
+            </a:r>
+          </a:p>
+          <a:p>
+            <a:pPr marL="514350" indent="-514350" algn="just" rtl="1">
+              <a:lnSpc>
+                <a:spcPct val="100000"/>
+              </a:lnSpc>
+              <a:spcBef>
+                <a:spcPts val="300"/>
+              </a:spcBef>
+              <a:buNone/>
+            </a:pPr>
+            <a:r>
+              <a:rPr lang="he-IL" sz="1700" b="1" dirty="0">
+                <a:cs typeface="+mn-cs"/>
+              </a:rPr>
+              <a:t>6-  </a:t>
+            </a:r>
+            <a:r>
+              <a:rPr lang="he-IL" sz="1700" b="1" dirty="0">
+                <a:cs typeface="+mn-cs"/>
+              </a:rPr>
+              <a:t>בחינת הרחבת הזימון היזום לגילאי 45 עד 49</a:t>
+            </a:r>
+            <a:r>
+              <a:rPr lang="he-IL" sz="1700" dirty="0">
+                <a:cs typeface="+mn-cs"/>
+              </a:rPr>
+              <a:t> בקהילות שבהן חציון גיל האבחון צעיר, ובראשן החברה הבדואית בנגב.</a:t>
             </a:r>
           </a:p>
         </p:txBody>

</xml_diff>